<commit_message>
Replace Slide 10 with a production deployment roadmap
Swaps the tradeoffs/exclusions slide for a dedicated CI/CD roadmap:
Application repo -> CI pipeline -> Container registry -> GitOps repo
-> Argo CD -> Kubernetes production cluster, with short connector
labels, plus four short cards (repository separation, CI pipeline,
Argo CD deployment, production reliability). An italic caption makes
explicit this is a proposed future design, not part of the current
take-home deployment. The tradeoffs/exclusions content that slide
previously carried on-screen was folded into this slide's speaker
notes for Q&A rather than dropped.

No other slide, layout, wording, image, or design was touched -
confirmed via a scoped diff and a full re-render of all 10 slides.

Co-Authored-By: Claude Sonnet 5 <noreply@anthropic.com>
Claude-Session: https://claude.ai/code/session_01VfFFZbU9d2vdYQxdRAKvrv
</commit_message>
<xml_diff>
--- a/presentation/ConvoScore-Presentation.pptx
+++ b/presentation/ConvoScore-Presentation.pptx
@@ -581,7 +581,13 @@
           <a:lstStyle/>
           <a:p>
             <a:r>
-              <a:t>This slide is deliberately unflattering on the left and forward-looking on the right. Every item on the left is something I found or decided, not something a reviewer would have to find themselves. On the right: frame it as 'what I'd do next with more time and a real budget,' not 'what's missing from this submission' - the take-home was deliberately scoped smaller than this list on purpose. Note the duplicate-call window is narrowed by an idempotency key, not solved outright - a transactional outbox pattern doesn't apply here since the non-atomic boundary is an external OpenAI call, not two local writes. Other production gaps worth naming if asked: Prometheus/Grafana storage is emptyDir today (no history across restarts), Grafana uses anonymous viewer access, and cost figures are estimates from a hardcoded pricing table - all explicit, documented tradeoffs for a local take-home, not oversights.</a:t>
+              <a:t>This is a proposed future CI/CD path, not something implemented in this take-home - worth being explicit about that distinction if asked. The flow: a commit to the application repo triggers CI (tests, security scanning, image build, SHA tag, push to a registry), which then updates the image tag in a separate GitOps repo; Argo CD watches that repo and reconciles the cluster to match it. Rollback becomes 'revert a Git commit,' not 'run a manual kubectl command.' Separating the GitOps repo from the application repo also means environment-specific Helm values (dev/staging/prod) never need to touch the application codebase.</a:t>
+            </a:r>
+          </a:p>
+          <a:p/>
+          <a:p>
+            <a:r>
+              <a:t>Honest tradeoffs/exclusions worth naming if asked, since they're not their own slide anymore: no exactly-once processing claim anywhere (SQS is at-least-once by design); a crash between an OpenAI response and the DB commit can still cause one extra paid call, bounded and rare, not eliminated (narrowed - not solved - by an idempotency key on the LLM call, not a transactional outbox, since the non-atomic boundary is an external API call, not two local writes); LocalStack doesn't enforce the IAM policies Terraform defines; and the take-home was scoped down on purpose - no CI, no service mesh, no ORM, no new database.</a:t>
             </a:r>
           </a:p>
         </p:txBody>
@@ -4449,7 +4455,7 @@
                 </a:solidFill>
                 <a:latin typeface="Segoe UI"/>
               </a:rPr>
-              <a:t>HONEST TRADEOFFS</a:t>
+              <a:t>LOOKING AHEAD</a:t>
             </a:r>
           </a:p>
         </p:txBody>
@@ -4483,7 +4489,7 @@
                 </a:solidFill>
                 <a:latin typeface="Segoe UI"/>
               </a:rPr>
-              <a:t>What this skips, and what changes in production</a:t>
+              <a:t>Production deployment roadmap</a:t>
             </a:r>
           </a:p>
         </p:txBody>
@@ -4534,14 +4540,762 @@
       </p:sp>
       <p:sp>
         <p:nvSpPr>
-          <p:cNvPr id="5" name="Rounded Rectangle 4"/>
+          <p:cNvPr id="5" name="TextBox 4"/>
+          <p:cNvSpPr txBox="1"/>
+          <p:nvPr/>
+        </p:nvSpPr>
+        <p:spPr>
+          <a:xfrm>
+            <a:off x="640080" y="1444752"/>
+            <a:ext cx="10607040" cy="274320"/>
+          </a:xfrm>
+          <a:prstGeom prst="rect">
+            <a:avLst/>
+          </a:prstGeom>
+          <a:noFill/>
+        </p:spPr>
+        <p:txBody>
+          <a:bodyPr wrap="none">
+            <a:spAutoFit/>
+          </a:bodyPr>
+          <a:lstStyle/>
+          <a:p>
+            <a:r>
+              <a:rPr sz="1200" b="0" i="1">
+                <a:solidFill>
+                  <a:srgbClr val="626E79"/>
+                </a:solidFill>
+                <a:latin typeface="Segoe UI"/>
+              </a:rPr>
+              <a:t>A proposed CI/CD path for production — not part of this take-home's current deployment</a:t>
+            </a:r>
+          </a:p>
+        </p:txBody>
+      </p:sp>
+      <p:sp>
+        <p:nvSpPr>
+          <p:cNvPr id="6" name="Rounded Rectangle 5"/>
           <p:cNvSpPr/>
           <p:nvPr/>
         </p:nvSpPr>
         <p:spPr>
           <a:xfrm>
-            <a:off x="640080" y="1737360"/>
-            <a:ext cx="5074920" cy="4206240"/>
+            <a:off x="640080" y="1874519"/>
+            <a:ext cx="1600200" cy="868680"/>
+          </a:xfrm>
+          <a:prstGeom prst="roundRect">
+            <a:avLst>
+              <a:gd name="adj" fmla="val 12000"/>
+            </a:avLst>
+          </a:prstGeom>
+          <a:solidFill>
+            <a:srgbClr val="4A5A6A"/>
+          </a:solidFill>
+          <a:ln>
+            <a:noFill/>
+          </a:ln>
+          <a:effectLst/>
+        </p:spPr>
+        <p:style>
+          <a:lnRef idx="1">
+            <a:schemeClr val="accent1"/>
+          </a:lnRef>
+          <a:fillRef idx="3">
+            <a:schemeClr val="accent1"/>
+          </a:fillRef>
+          <a:effectRef idx="2">
+            <a:schemeClr val="accent1"/>
+          </a:effectRef>
+          <a:fontRef idx="minor">
+            <a:schemeClr val="lt1"/>
+          </a:fontRef>
+        </p:style>
+        <p:txBody>
+          <a:bodyPr rtlCol="0" anchor="ctr" wrap="square" lIns="50800" rIns="50800"/>
+          <a:lstStyle/>
+          <a:p>
+            <a:pPr algn="ctr">
+              <a:lnSpc>
+                <a:spcPct val="100000"/>
+              </a:lnSpc>
+            </a:pPr>
+            <a:r>
+              <a:rPr sz="1250" b="1" i="0">
+                <a:solidFill>
+                  <a:srgbClr val="FFFFFF"/>
+                </a:solidFill>
+                <a:latin typeface="Segoe UI"/>
+              </a:rPr>
+              <a:t>Application
+repository</a:t>
+            </a:r>
+          </a:p>
+        </p:txBody>
+      </p:sp>
+      <p:sp>
+        <p:nvSpPr>
+          <p:cNvPr id="7" name="Rounded Rectangle 6"/>
+          <p:cNvSpPr/>
+          <p:nvPr/>
+        </p:nvSpPr>
+        <p:spPr>
+          <a:xfrm>
+            <a:off x="2441448" y="1874519"/>
+            <a:ext cx="1600200" cy="868680"/>
+          </a:xfrm>
+          <a:prstGeom prst="roundRect">
+            <a:avLst>
+              <a:gd name="adj" fmla="val 12000"/>
+            </a:avLst>
+          </a:prstGeom>
+          <a:solidFill>
+            <a:srgbClr val="168A86"/>
+          </a:solidFill>
+          <a:ln>
+            <a:noFill/>
+          </a:ln>
+          <a:effectLst/>
+        </p:spPr>
+        <p:style>
+          <a:lnRef idx="1">
+            <a:schemeClr val="accent1"/>
+          </a:lnRef>
+          <a:fillRef idx="3">
+            <a:schemeClr val="accent1"/>
+          </a:fillRef>
+          <a:effectRef idx="2">
+            <a:schemeClr val="accent1"/>
+          </a:effectRef>
+          <a:fontRef idx="minor">
+            <a:schemeClr val="lt1"/>
+          </a:fontRef>
+        </p:style>
+        <p:txBody>
+          <a:bodyPr rtlCol="0" anchor="ctr" wrap="square" lIns="50800" rIns="50800"/>
+          <a:lstStyle/>
+          <a:p>
+            <a:pPr algn="ctr">
+              <a:lnSpc>
+                <a:spcPct val="100000"/>
+              </a:lnSpc>
+            </a:pPr>
+            <a:r>
+              <a:rPr sz="1250" b="1" i="0">
+                <a:solidFill>
+                  <a:srgbClr val="FFFFFF"/>
+                </a:solidFill>
+                <a:latin typeface="Segoe UI"/>
+              </a:rPr>
+              <a:t>CI pipeline</a:t>
+            </a:r>
+          </a:p>
+        </p:txBody>
+      </p:sp>
+      <p:sp>
+        <p:nvSpPr>
+          <p:cNvPr id="8" name="Rounded Rectangle 7"/>
+          <p:cNvSpPr/>
+          <p:nvPr/>
+        </p:nvSpPr>
+        <p:spPr>
+          <a:xfrm>
+            <a:off x="4242816" y="1874519"/>
+            <a:ext cx="1600200" cy="868680"/>
+          </a:xfrm>
+          <a:prstGeom prst="roundRect">
+            <a:avLst>
+              <a:gd name="adj" fmla="val 12000"/>
+            </a:avLst>
+          </a:prstGeom>
+          <a:solidFill>
+            <a:srgbClr val="4A5A6A"/>
+          </a:solidFill>
+          <a:ln>
+            <a:noFill/>
+          </a:ln>
+          <a:effectLst/>
+        </p:spPr>
+        <p:style>
+          <a:lnRef idx="1">
+            <a:schemeClr val="accent1"/>
+          </a:lnRef>
+          <a:fillRef idx="3">
+            <a:schemeClr val="accent1"/>
+          </a:fillRef>
+          <a:effectRef idx="2">
+            <a:schemeClr val="accent1"/>
+          </a:effectRef>
+          <a:fontRef idx="minor">
+            <a:schemeClr val="lt1"/>
+          </a:fontRef>
+        </p:style>
+        <p:txBody>
+          <a:bodyPr rtlCol="0" anchor="ctr" wrap="square" lIns="50800" rIns="50800"/>
+          <a:lstStyle/>
+          <a:p>
+            <a:pPr algn="ctr">
+              <a:lnSpc>
+                <a:spcPct val="100000"/>
+              </a:lnSpc>
+            </a:pPr>
+            <a:r>
+              <a:rPr sz="1250" b="1" i="0">
+                <a:solidFill>
+                  <a:srgbClr val="FFFFFF"/>
+                </a:solidFill>
+                <a:latin typeface="Segoe UI"/>
+              </a:rPr>
+              <a:t>Container
+registry</a:t>
+            </a:r>
+          </a:p>
+        </p:txBody>
+      </p:sp>
+      <p:sp>
+        <p:nvSpPr>
+          <p:cNvPr id="9" name="Rounded Rectangle 8"/>
+          <p:cNvSpPr/>
+          <p:nvPr/>
+        </p:nvSpPr>
+        <p:spPr>
+          <a:xfrm>
+            <a:off x="6044184" y="1874519"/>
+            <a:ext cx="1600200" cy="868680"/>
+          </a:xfrm>
+          <a:prstGeom prst="roundRect">
+            <a:avLst>
+              <a:gd name="adj" fmla="val 12000"/>
+            </a:avLst>
+          </a:prstGeom>
+          <a:solidFill>
+            <a:srgbClr val="C97A1A"/>
+          </a:solidFill>
+          <a:ln>
+            <a:noFill/>
+          </a:ln>
+          <a:effectLst/>
+        </p:spPr>
+        <p:style>
+          <a:lnRef idx="1">
+            <a:schemeClr val="accent1"/>
+          </a:lnRef>
+          <a:fillRef idx="3">
+            <a:schemeClr val="accent1"/>
+          </a:fillRef>
+          <a:effectRef idx="2">
+            <a:schemeClr val="accent1"/>
+          </a:effectRef>
+          <a:fontRef idx="minor">
+            <a:schemeClr val="lt1"/>
+          </a:fontRef>
+        </p:style>
+        <p:txBody>
+          <a:bodyPr rtlCol="0" anchor="ctr" wrap="square" lIns="50800" rIns="50800"/>
+          <a:lstStyle/>
+          <a:p>
+            <a:pPr algn="ctr">
+              <a:lnSpc>
+                <a:spcPct val="100000"/>
+              </a:lnSpc>
+            </a:pPr>
+            <a:r>
+              <a:rPr sz="1250" b="1" i="0">
+                <a:solidFill>
+                  <a:srgbClr val="FFFFFF"/>
+                </a:solidFill>
+                <a:latin typeface="Segoe UI"/>
+              </a:rPr>
+              <a:t>GitOps
+repository</a:t>
+            </a:r>
+          </a:p>
+        </p:txBody>
+      </p:sp>
+      <p:sp>
+        <p:nvSpPr>
+          <p:cNvPr id="10" name="Rounded Rectangle 9"/>
+          <p:cNvSpPr/>
+          <p:nvPr/>
+        </p:nvSpPr>
+        <p:spPr>
+          <a:xfrm>
+            <a:off x="7845552" y="1874519"/>
+            <a:ext cx="1600200" cy="868680"/>
+          </a:xfrm>
+          <a:prstGeom prst="roundRect">
+            <a:avLst>
+              <a:gd name="adj" fmla="val 12000"/>
+            </a:avLst>
+          </a:prstGeom>
+          <a:solidFill>
+            <a:srgbClr val="0F6664"/>
+          </a:solidFill>
+          <a:ln>
+            <a:noFill/>
+          </a:ln>
+          <a:effectLst/>
+        </p:spPr>
+        <p:style>
+          <a:lnRef idx="1">
+            <a:schemeClr val="accent1"/>
+          </a:lnRef>
+          <a:fillRef idx="3">
+            <a:schemeClr val="accent1"/>
+          </a:fillRef>
+          <a:effectRef idx="2">
+            <a:schemeClr val="accent1"/>
+          </a:effectRef>
+          <a:fontRef idx="minor">
+            <a:schemeClr val="lt1"/>
+          </a:fontRef>
+        </p:style>
+        <p:txBody>
+          <a:bodyPr rtlCol="0" anchor="ctr" wrap="square" lIns="50800" rIns="50800"/>
+          <a:lstStyle/>
+          <a:p>
+            <a:pPr algn="ctr">
+              <a:lnSpc>
+                <a:spcPct val="100000"/>
+              </a:lnSpc>
+            </a:pPr>
+            <a:r>
+              <a:rPr sz="1250" b="1" i="0">
+                <a:solidFill>
+                  <a:srgbClr val="FFFFFF"/>
+                </a:solidFill>
+                <a:latin typeface="Segoe UI"/>
+              </a:rPr>
+              <a:t>Argo CD</a:t>
+            </a:r>
+          </a:p>
+        </p:txBody>
+      </p:sp>
+      <p:sp>
+        <p:nvSpPr>
+          <p:cNvPr id="11" name="Rounded Rectangle 10"/>
+          <p:cNvSpPr/>
+          <p:nvPr/>
+        </p:nvSpPr>
+        <p:spPr>
+          <a:xfrm>
+            <a:off x="9646919" y="1874519"/>
+            <a:ext cx="1600200" cy="868680"/>
+          </a:xfrm>
+          <a:prstGeom prst="roundRect">
+            <a:avLst>
+              <a:gd name="adj" fmla="val 12000"/>
+            </a:avLst>
+          </a:prstGeom>
+          <a:solidFill>
+            <a:srgbClr val="14253A"/>
+          </a:solidFill>
+          <a:ln>
+            <a:noFill/>
+          </a:ln>
+          <a:effectLst/>
+        </p:spPr>
+        <p:style>
+          <a:lnRef idx="1">
+            <a:schemeClr val="accent1"/>
+          </a:lnRef>
+          <a:fillRef idx="3">
+            <a:schemeClr val="accent1"/>
+          </a:fillRef>
+          <a:effectRef idx="2">
+            <a:schemeClr val="accent1"/>
+          </a:effectRef>
+          <a:fontRef idx="minor">
+            <a:schemeClr val="lt1"/>
+          </a:fontRef>
+        </p:style>
+        <p:txBody>
+          <a:bodyPr rtlCol="0" anchor="ctr" wrap="square" lIns="50800" rIns="50800"/>
+          <a:lstStyle/>
+          <a:p>
+            <a:pPr algn="ctr">
+              <a:lnSpc>
+                <a:spcPct val="100000"/>
+              </a:lnSpc>
+            </a:pPr>
+            <a:r>
+              <a:rPr sz="1150" b="1" i="0">
+                <a:solidFill>
+                  <a:srgbClr val="FFFFFF"/>
+                </a:solidFill>
+                <a:latin typeface="Segoe UI"/>
+              </a:rPr>
+              <a:t>Kubernetes
+production
+cluster</a:t>
+            </a:r>
+          </a:p>
+        </p:txBody>
+      </p:sp>
+      <p:cxnSp>
+        <p:nvCxnSpPr>
+          <p:cNvPr id="12" name="Connector 11"/>
+          <p:cNvCxnSpPr/>
+          <p:nvPr/>
+        </p:nvCxnSpPr>
+        <p:spPr>
+          <a:xfrm>
+            <a:off x="2240280" y="2308860"/>
+            <a:ext cx="201168" cy="0"/>
+          </a:xfrm>
+          <a:prstGeom prst="line">
+            <a:avLst/>
+          </a:prstGeom>
+          <a:ln w="22225">
+            <a:solidFill>
+              <a:srgbClr val="4A5A6A"/>
+            </a:solidFill>
+            <a:tailEnd type="triangle" w="med" len="med"/>
+          </a:ln>
+        </p:spPr>
+        <p:style>
+          <a:lnRef idx="2">
+            <a:schemeClr val="accent1"/>
+          </a:lnRef>
+          <a:fillRef idx="0">
+            <a:schemeClr val="accent1"/>
+          </a:fillRef>
+          <a:effectRef idx="1">
+            <a:schemeClr val="accent1"/>
+          </a:effectRef>
+          <a:fontRef idx="minor">
+            <a:schemeClr val="tx1"/>
+          </a:fontRef>
+        </p:style>
+      </p:cxnSp>
+      <p:sp>
+        <p:nvSpPr>
+          <p:cNvPr id="13" name="TextBox 12"/>
+          <p:cNvSpPr txBox="1"/>
+          <p:nvPr/>
+        </p:nvSpPr>
+        <p:spPr>
+          <a:xfrm>
+            <a:off x="1540764" y="2834640"/>
+            <a:ext cx="1600200" cy="274320"/>
+          </a:xfrm>
+          <a:prstGeom prst="rect">
+            <a:avLst/>
+          </a:prstGeom>
+          <a:noFill/>
+        </p:spPr>
+        <p:txBody>
+          <a:bodyPr wrap="none" lIns="0" rIns="0">
+            <a:spAutoFit/>
+          </a:bodyPr>
+          <a:lstStyle/>
+          <a:p>
+            <a:pPr algn="ctr"/>
+            <a:r>
+              <a:rPr sz="1050" b="0" i="0">
+                <a:solidFill>
+                  <a:srgbClr val="626E79"/>
+                </a:solidFill>
+                <a:latin typeface="Segoe UI"/>
+              </a:rPr>
+              <a:t>commit</a:t>
+            </a:r>
+          </a:p>
+        </p:txBody>
+      </p:sp>
+      <p:cxnSp>
+        <p:nvCxnSpPr>
+          <p:cNvPr id="14" name="Connector 13"/>
+          <p:cNvCxnSpPr/>
+          <p:nvPr/>
+        </p:nvCxnSpPr>
+        <p:spPr>
+          <a:xfrm>
+            <a:off x="4041648" y="2308860"/>
+            <a:ext cx="201168" cy="0"/>
+          </a:xfrm>
+          <a:prstGeom prst="line">
+            <a:avLst/>
+          </a:prstGeom>
+          <a:ln w="22225">
+            <a:solidFill>
+              <a:srgbClr val="4A5A6A"/>
+            </a:solidFill>
+            <a:tailEnd type="triangle" w="med" len="med"/>
+          </a:ln>
+        </p:spPr>
+        <p:style>
+          <a:lnRef idx="2">
+            <a:schemeClr val="accent1"/>
+          </a:lnRef>
+          <a:fillRef idx="0">
+            <a:schemeClr val="accent1"/>
+          </a:fillRef>
+          <a:effectRef idx="1">
+            <a:schemeClr val="accent1"/>
+          </a:effectRef>
+          <a:fontRef idx="minor">
+            <a:schemeClr val="tx1"/>
+          </a:fontRef>
+        </p:style>
+      </p:cxnSp>
+      <p:sp>
+        <p:nvSpPr>
+          <p:cNvPr id="15" name="TextBox 14"/>
+          <p:cNvSpPr txBox="1"/>
+          <p:nvPr/>
+        </p:nvSpPr>
+        <p:spPr>
+          <a:xfrm>
+            <a:off x="3342131" y="2834640"/>
+            <a:ext cx="1600200" cy="274320"/>
+          </a:xfrm>
+          <a:prstGeom prst="rect">
+            <a:avLst/>
+          </a:prstGeom>
+          <a:noFill/>
+        </p:spPr>
+        <p:txBody>
+          <a:bodyPr wrap="none" lIns="0" rIns="0">
+            <a:spAutoFit/>
+          </a:bodyPr>
+          <a:lstStyle/>
+          <a:p>
+            <a:pPr algn="ctr"/>
+            <a:r>
+              <a:rPr sz="1050" b="0" i="0">
+                <a:solidFill>
+                  <a:srgbClr val="626E79"/>
+                </a:solidFill>
+                <a:latin typeface="Segoe UI"/>
+              </a:rPr>
+              <a:t>build &amp; push</a:t>
+            </a:r>
+          </a:p>
+        </p:txBody>
+      </p:sp>
+      <p:cxnSp>
+        <p:nvCxnSpPr>
+          <p:cNvPr id="16" name="Connector 15"/>
+          <p:cNvCxnSpPr/>
+          <p:nvPr/>
+        </p:nvCxnSpPr>
+        <p:spPr>
+          <a:xfrm>
+            <a:off x="5843016" y="2308860"/>
+            <a:ext cx="201168" cy="0"/>
+          </a:xfrm>
+          <a:prstGeom prst="line">
+            <a:avLst/>
+          </a:prstGeom>
+          <a:ln w="22225">
+            <a:solidFill>
+              <a:srgbClr val="4A5A6A"/>
+            </a:solidFill>
+            <a:tailEnd type="triangle" w="med" len="med"/>
+          </a:ln>
+        </p:spPr>
+        <p:style>
+          <a:lnRef idx="2">
+            <a:schemeClr val="accent1"/>
+          </a:lnRef>
+          <a:fillRef idx="0">
+            <a:schemeClr val="accent1"/>
+          </a:fillRef>
+          <a:effectRef idx="1">
+            <a:schemeClr val="accent1"/>
+          </a:effectRef>
+          <a:fontRef idx="minor">
+            <a:schemeClr val="tx1"/>
+          </a:fontRef>
+        </p:style>
+      </p:cxnSp>
+      <p:sp>
+        <p:nvSpPr>
+          <p:cNvPr id="17" name="TextBox 16"/>
+          <p:cNvSpPr txBox="1"/>
+          <p:nvPr/>
+        </p:nvSpPr>
+        <p:spPr>
+          <a:xfrm>
+            <a:off x="5143500" y="2834640"/>
+            <a:ext cx="1600200" cy="274320"/>
+          </a:xfrm>
+          <a:prstGeom prst="rect">
+            <a:avLst/>
+          </a:prstGeom>
+          <a:noFill/>
+        </p:spPr>
+        <p:txBody>
+          <a:bodyPr wrap="none" lIns="0" rIns="0">
+            <a:spAutoFit/>
+          </a:bodyPr>
+          <a:lstStyle/>
+          <a:p>
+            <a:pPr algn="ctr"/>
+            <a:r>
+              <a:rPr sz="1050" b="0" i="0">
+                <a:solidFill>
+                  <a:srgbClr val="626E79"/>
+                </a:solidFill>
+                <a:latin typeface="Segoe UI"/>
+              </a:rPr>
+              <a:t>update tag</a:t>
+            </a:r>
+          </a:p>
+        </p:txBody>
+      </p:sp>
+      <p:cxnSp>
+        <p:nvCxnSpPr>
+          <p:cNvPr id="18" name="Connector 17"/>
+          <p:cNvCxnSpPr/>
+          <p:nvPr/>
+        </p:nvCxnSpPr>
+        <p:spPr>
+          <a:xfrm>
+            <a:off x="7644383" y="2308860"/>
+            <a:ext cx="201169" cy="0"/>
+          </a:xfrm>
+          <a:prstGeom prst="line">
+            <a:avLst/>
+          </a:prstGeom>
+          <a:ln w="22225">
+            <a:solidFill>
+              <a:srgbClr val="4A5A6A"/>
+            </a:solidFill>
+            <a:tailEnd type="triangle" w="med" len="med"/>
+          </a:ln>
+        </p:spPr>
+        <p:style>
+          <a:lnRef idx="2">
+            <a:schemeClr val="accent1"/>
+          </a:lnRef>
+          <a:fillRef idx="0">
+            <a:schemeClr val="accent1"/>
+          </a:fillRef>
+          <a:effectRef idx="1">
+            <a:schemeClr val="accent1"/>
+          </a:effectRef>
+          <a:fontRef idx="minor">
+            <a:schemeClr val="tx1"/>
+          </a:fontRef>
+        </p:style>
+      </p:cxnSp>
+      <p:sp>
+        <p:nvSpPr>
+          <p:cNvPr id="19" name="TextBox 18"/>
+          <p:cNvSpPr txBox="1"/>
+          <p:nvPr/>
+        </p:nvSpPr>
+        <p:spPr>
+          <a:xfrm>
+            <a:off x="6944867" y="2834640"/>
+            <a:ext cx="1600200" cy="274320"/>
+          </a:xfrm>
+          <a:prstGeom prst="rect">
+            <a:avLst/>
+          </a:prstGeom>
+          <a:noFill/>
+        </p:spPr>
+        <p:txBody>
+          <a:bodyPr wrap="none" lIns="0" rIns="0">
+            <a:spAutoFit/>
+          </a:bodyPr>
+          <a:lstStyle/>
+          <a:p>
+            <a:pPr algn="ctr"/>
+            <a:r>
+              <a:rPr sz="1050" b="0" i="0">
+                <a:solidFill>
+                  <a:srgbClr val="626E79"/>
+                </a:solidFill>
+                <a:latin typeface="Segoe UI"/>
+              </a:rPr>
+              <a:t>git sync</a:t>
+            </a:r>
+          </a:p>
+        </p:txBody>
+      </p:sp>
+      <p:cxnSp>
+        <p:nvCxnSpPr>
+          <p:cNvPr id="20" name="Connector 19"/>
+          <p:cNvCxnSpPr/>
+          <p:nvPr/>
+        </p:nvCxnSpPr>
+        <p:spPr>
+          <a:xfrm>
+            <a:off x="9445752" y="2308860"/>
+            <a:ext cx="201167" cy="0"/>
+          </a:xfrm>
+          <a:prstGeom prst="line">
+            <a:avLst/>
+          </a:prstGeom>
+          <a:ln w="22225">
+            <a:solidFill>
+              <a:srgbClr val="4A5A6A"/>
+            </a:solidFill>
+            <a:tailEnd type="triangle" w="med" len="med"/>
+          </a:ln>
+        </p:spPr>
+        <p:style>
+          <a:lnRef idx="2">
+            <a:schemeClr val="accent1"/>
+          </a:lnRef>
+          <a:fillRef idx="0">
+            <a:schemeClr val="accent1"/>
+          </a:fillRef>
+          <a:effectRef idx="1">
+            <a:schemeClr val="accent1"/>
+          </a:effectRef>
+          <a:fontRef idx="minor">
+            <a:schemeClr val="tx1"/>
+          </a:fontRef>
+        </p:style>
+      </p:cxnSp>
+      <p:sp>
+        <p:nvSpPr>
+          <p:cNvPr id="21" name="TextBox 20"/>
+          <p:cNvSpPr txBox="1"/>
+          <p:nvPr/>
+        </p:nvSpPr>
+        <p:spPr>
+          <a:xfrm>
+            <a:off x="8746236" y="2834640"/>
+            <a:ext cx="1600200" cy="274320"/>
+          </a:xfrm>
+          <a:prstGeom prst="rect">
+            <a:avLst/>
+          </a:prstGeom>
+          <a:noFill/>
+        </p:spPr>
+        <p:txBody>
+          <a:bodyPr wrap="none" lIns="0" rIns="0">
+            <a:spAutoFit/>
+          </a:bodyPr>
+          <a:lstStyle/>
+          <a:p>
+            <a:pPr algn="ctr"/>
+            <a:r>
+              <a:rPr sz="1050" b="0" i="0">
+                <a:solidFill>
+                  <a:srgbClr val="626E79"/>
+                </a:solidFill>
+                <a:latin typeface="Segoe UI"/>
+              </a:rPr>
+              <a:t>deploy</a:t>
+            </a:r>
+          </a:p>
+        </p:txBody>
+      </p:sp>
+      <p:sp>
+        <p:nvSpPr>
+          <p:cNvPr id="22" name="Rounded Rectangle 21"/>
+          <p:cNvSpPr/>
+          <p:nvPr/>
+        </p:nvSpPr>
+        <p:spPr>
+          <a:xfrm>
+            <a:off x="640080" y="3337560"/>
+            <a:ext cx="5074920" cy="1234440"/>
           </a:xfrm>
           <a:prstGeom prst="roundRect">
             <a:avLst>
@@ -4582,20 +5336,20 @@
       </p:sp>
       <p:sp>
         <p:nvSpPr>
-          <p:cNvPr id="6" name="Rectangle 5"/>
+          <p:cNvPr id="23" name="Rectangle 22"/>
           <p:cNvSpPr/>
           <p:nvPr/>
         </p:nvSpPr>
         <p:spPr>
           <a:xfrm>
-            <a:off x="786384" y="1737360"/>
+            <a:off x="786384" y="3337560"/>
             <a:ext cx="4782312" cy="40640"/>
           </a:xfrm>
           <a:prstGeom prst="rect">
             <a:avLst/>
           </a:prstGeom>
           <a:solidFill>
-            <a:srgbClr val="9E3533"/>
+            <a:srgbClr val="4A5A6A"/>
           </a:solidFill>
           <a:ln>
             <a:noFill/>
@@ -4626,14 +5380,67 @@
       </p:sp>
       <p:sp>
         <p:nvSpPr>
-          <p:cNvPr id="7" name="TextBox 6"/>
+          <p:cNvPr id="24" name="Oval 23"/>
+          <p:cNvSpPr/>
+          <p:nvPr/>
+        </p:nvSpPr>
+        <p:spPr>
+          <a:xfrm>
+            <a:off x="868680" y="3520440"/>
+            <a:ext cx="292608" cy="292608"/>
+          </a:xfrm>
+          <a:prstGeom prst="ellipse">
+            <a:avLst/>
+          </a:prstGeom>
+          <a:solidFill>
+            <a:srgbClr val="4A5A6A"/>
+          </a:solidFill>
+          <a:ln>
+            <a:noFill/>
+          </a:ln>
+          <a:effectLst/>
+        </p:spPr>
+        <p:style>
+          <a:lnRef idx="1">
+            <a:schemeClr val="accent1"/>
+          </a:lnRef>
+          <a:fillRef idx="3">
+            <a:schemeClr val="accent1"/>
+          </a:fillRef>
+          <a:effectRef idx="2">
+            <a:schemeClr val="accent1"/>
+          </a:effectRef>
+          <a:fontRef idx="minor">
+            <a:schemeClr val="lt1"/>
+          </a:fontRef>
+        </p:style>
+        <p:txBody>
+          <a:bodyPr rtlCol="0" anchor="ctr" wrap="none" lIns="0" rIns="0"/>
+          <a:lstStyle/>
+          <a:p>
+            <a:pPr algn="ctr"/>
+            <a:r>
+              <a:rPr sz="1250" b="1" i="0">
+                <a:solidFill>
+                  <a:srgbClr val="FFFFFF"/>
+                </a:solidFill>
+                <a:latin typeface="Segoe UI"/>
+              </a:rPr>
+              <a:t>1</a:t>
+            </a:r>
+          </a:p>
+        </p:txBody>
+      </p:sp>
+      <p:sp>
+        <p:nvSpPr>
+          <p:cNvPr id="25" name="TextBox 24"/>
           <p:cNvSpPr txBox="1"/>
           <p:nvPr/>
         </p:nvSpPr>
         <p:spPr>
           <a:xfrm>
-            <a:off x="914400" y="1920240"/>
-            <a:ext cx="4572000" cy="365760"/>
+            <a:off x="1280160" y="3474720"/>
+            <a:ext cx="4160520" cy="320040"/>
           </a:xfrm>
           <a:prstGeom prst="rect">
             <a:avLst/>
@@ -4647,27 +5454,27 @@
           <a:lstStyle/>
           <a:p>
             <a:r>
-              <a:rPr sz="1600" b="1" i="0">
-                <a:solidFill>
-                  <a:srgbClr val="9E3533"/>
-                </a:solidFill>
-                <a:latin typeface="Segoe UI"/>
-              </a:rPr>
-              <a:t>Tradeoffs &amp; exclusions</a:t>
-            </a:r>
-          </a:p>
-        </p:txBody>
-      </p:sp>
-      <p:sp>
-        <p:nvSpPr>
-          <p:cNvPr id="8" name="TextBox 7"/>
+              <a:rPr sz="1450" b="1" i="0">
+                <a:solidFill>
+                  <a:srgbClr val="14253A"/>
+                </a:solidFill>
+                <a:latin typeface="Segoe UI"/>
+              </a:rPr>
+              <a:t>Repository separation</a:t>
+            </a:r>
+          </a:p>
+        </p:txBody>
+      </p:sp>
+      <p:sp>
+        <p:nvSpPr>
+          <p:cNvPr id="26" name="TextBox 25"/>
           <p:cNvSpPr txBox="1"/>
           <p:nvPr/>
         </p:nvSpPr>
         <p:spPr>
           <a:xfrm>
-            <a:off x="914400" y="2395728"/>
-            <a:ext cx="4526280" cy="3474720"/>
+            <a:off x="868680" y="3867911"/>
+            <a:ext cx="4617720" cy="640080"/>
           </a:xfrm>
           <a:prstGeom prst="rect">
             <a:avLst/>
@@ -4682,163 +5489,31 @@
           <a:p>
             <a:pPr>
               <a:lnSpc>
-                <a:spcPct val="110000"/>
+                <a:spcPct val="105000"/>
               </a:lnSpc>
-              <a:spcAft>
-                <a:spcPts val="1300"/>
-              </a:spcAft>
             </a:pPr>
             <a:r>
-              <a:rPr sz="1280" b="1" i="0">
-                <a:solidFill>
-                  <a:srgbClr val="9E3533"/>
-                </a:solidFill>
-                <a:latin typeface="Segoe UI"/>
-              </a:rPr>
-              <a:t>▸  </a:t>
-            </a:r>
-            <a:r>
-              <a:rPr sz="1280" b="1" i="0">
-                <a:solidFill>
-                  <a:srgbClr val="14253A"/>
-                </a:solidFill>
-                <a:latin typeface="Segoe UI"/>
-              </a:rPr>
-              <a:t>No exactly-once claim anywhere</a:t>
-            </a:r>
-            <a:r>
-              <a:rPr sz="1280" b="0" i="0">
+              <a:rPr sz="1250" b="0" i="0">
                 <a:solidFill>
                   <a:srgbClr val="1E242B"/>
                 </a:solidFill>
                 <a:latin typeface="Segoe UI"/>
               </a:rPr>
-              <a:t> — SQS is at-least-once by design</a:t>
-            </a:r>
-          </a:p>
-          <a:p>
-            <a:pPr>
-              <a:lnSpc>
-                <a:spcPct val="110000"/>
-              </a:lnSpc>
-              <a:spcAft>
-                <a:spcPts val="1300"/>
-              </a:spcAft>
-            </a:pPr>
-            <a:r>
-              <a:rPr sz="1280" b="1" i="0">
-                <a:solidFill>
-                  <a:srgbClr val="9E3533"/>
-                </a:solidFill>
-                <a:latin typeface="Segoe UI"/>
-              </a:rPr>
-              <a:t>▸  </a:t>
-            </a:r>
-            <a:r>
-              <a:rPr sz="1280" b="1" i="0">
-                <a:solidFill>
-                  <a:srgbClr val="14253A"/>
-                </a:solidFill>
-                <a:latin typeface="Segoe UI"/>
-              </a:rPr>
-              <a:t>A crash between an OpenAI response and the DB commit can still cause one extra paid call</a:t>
-            </a:r>
-            <a:r>
-              <a:rPr sz="1280" b="0" i="0">
-                <a:solidFill>
-                  <a:srgbClr val="1E242B"/>
-                </a:solidFill>
-                <a:latin typeface="Segoe UI"/>
-              </a:rPr>
-              <a:t> — bounded and rare, not eliminated</a:t>
-            </a:r>
-          </a:p>
-          <a:p>
-            <a:pPr>
-              <a:lnSpc>
-                <a:spcPct val="110000"/>
-              </a:lnSpc>
-              <a:spcAft>
-                <a:spcPts val="1300"/>
-              </a:spcAft>
-            </a:pPr>
-            <a:r>
-              <a:rPr sz="1280" b="1" i="0">
-                <a:solidFill>
-                  <a:srgbClr val="9E3533"/>
-                </a:solidFill>
-                <a:latin typeface="Segoe UI"/>
-              </a:rPr>
-              <a:t>▸  </a:t>
-            </a:r>
-            <a:r>
-              <a:rPr sz="1280" b="1" i="0">
-                <a:solidFill>
-                  <a:srgbClr val="14253A"/>
-                </a:solidFill>
-                <a:latin typeface="Segoe UI"/>
-              </a:rPr>
-              <a:t>LocalStack doesn't enforce the IAM policies Terraform defines</a:t>
-            </a:r>
-            <a:r>
-              <a:rPr sz="1280" b="0" i="0">
-                <a:solidFill>
-                  <a:srgbClr val="1E242B"/>
-                </a:solidFill>
-                <a:latin typeface="Segoe UI"/>
-              </a:rPr>
-              <a:t> — they show the intended shape for real AWS</a:t>
-            </a:r>
-          </a:p>
-          <a:p>
-            <a:pPr>
-              <a:lnSpc>
-                <a:spcPct val="110000"/>
-              </a:lnSpc>
-              <a:spcAft>
-                <a:spcPts val="1300"/>
-              </a:spcAft>
-            </a:pPr>
-            <a:r>
-              <a:rPr sz="1280" b="1" i="0">
-                <a:solidFill>
-                  <a:srgbClr val="9E3533"/>
-                </a:solidFill>
-                <a:latin typeface="Segoe UI"/>
-              </a:rPr>
-              <a:t>▸  </a:t>
-            </a:r>
-            <a:r>
-              <a:rPr sz="1280" b="1" i="0">
-                <a:solidFill>
-                  <a:srgbClr val="14253A"/>
-                </a:solidFill>
-                <a:latin typeface="Segoe UI"/>
-              </a:rPr>
-              <a:t>Scoped down on purpose</a:t>
-            </a:r>
-            <a:r>
-              <a:rPr sz="1280" b="0" i="0">
-                <a:solidFill>
-                  <a:srgbClr val="1E242B"/>
-                </a:solidFill>
-                <a:latin typeface="Segoe UI"/>
-              </a:rPr>
-              <a:t> — no CI, no service mesh, no ORM, no new database</a:t>
-            </a:r>
-          </a:p>
-        </p:txBody>
-      </p:sp>
-      <p:sp>
-        <p:nvSpPr>
-          <p:cNvPr id="9" name="Rounded Rectangle 8"/>
+              <a:t>App code and the Dockerfile stay here; Helm config moves to a separate GitOps repo — Terraform can split out too.</a:t>
+            </a:r>
+          </a:p>
+        </p:txBody>
+      </p:sp>
+      <p:sp>
+        <p:nvSpPr>
+          <p:cNvPr id="27" name="Rounded Rectangle 26"/>
           <p:cNvSpPr/>
           <p:nvPr/>
         </p:nvSpPr>
         <p:spPr>
           <a:xfrm>
-            <a:off x="6172200" y="1737360"/>
-            <a:ext cx="5074920" cy="4206240"/>
+            <a:off x="6172200" y="3337560"/>
+            <a:ext cx="5074920" cy="1234440"/>
           </a:xfrm>
           <a:prstGeom prst="roundRect">
             <a:avLst>
@@ -4879,13 +5554,13 @@
       </p:sp>
       <p:sp>
         <p:nvSpPr>
-          <p:cNvPr id="10" name="Rectangle 9"/>
+          <p:cNvPr id="28" name="Rectangle 27"/>
           <p:cNvSpPr/>
           <p:nvPr/>
         </p:nvSpPr>
         <p:spPr>
           <a:xfrm>
-            <a:off x="6318504" y="1737360"/>
+            <a:off x="6318504" y="3337560"/>
             <a:ext cx="4782312" cy="40640"/>
           </a:xfrm>
           <a:prstGeom prst="rect">
@@ -4923,14 +5598,67 @@
       </p:sp>
       <p:sp>
         <p:nvSpPr>
-          <p:cNvPr id="11" name="TextBox 10"/>
+          <p:cNvPr id="29" name="Oval 28"/>
+          <p:cNvSpPr/>
+          <p:nvPr/>
+        </p:nvSpPr>
+        <p:spPr>
+          <a:xfrm>
+            <a:off x="6400800" y="3520440"/>
+            <a:ext cx="292608" cy="292608"/>
+          </a:xfrm>
+          <a:prstGeom prst="ellipse">
+            <a:avLst/>
+          </a:prstGeom>
+          <a:solidFill>
+            <a:srgbClr val="168A86"/>
+          </a:solidFill>
+          <a:ln>
+            <a:noFill/>
+          </a:ln>
+          <a:effectLst/>
+        </p:spPr>
+        <p:style>
+          <a:lnRef idx="1">
+            <a:schemeClr val="accent1"/>
+          </a:lnRef>
+          <a:fillRef idx="3">
+            <a:schemeClr val="accent1"/>
+          </a:fillRef>
+          <a:effectRef idx="2">
+            <a:schemeClr val="accent1"/>
+          </a:effectRef>
+          <a:fontRef idx="minor">
+            <a:schemeClr val="lt1"/>
+          </a:fontRef>
+        </p:style>
+        <p:txBody>
+          <a:bodyPr rtlCol="0" anchor="ctr" wrap="none" lIns="0" rIns="0"/>
+          <a:lstStyle/>
+          <a:p>
+            <a:pPr algn="ctr"/>
+            <a:r>
+              <a:rPr sz="1250" b="1" i="0">
+                <a:solidFill>
+                  <a:srgbClr val="FFFFFF"/>
+                </a:solidFill>
+                <a:latin typeface="Segoe UI"/>
+              </a:rPr>
+              <a:t>2</a:t>
+            </a:r>
+          </a:p>
+        </p:txBody>
+      </p:sp>
+      <p:sp>
+        <p:nvSpPr>
+          <p:cNvPr id="30" name="TextBox 29"/>
           <p:cNvSpPr txBox="1"/>
           <p:nvPr/>
         </p:nvSpPr>
         <p:spPr>
           <a:xfrm>
-            <a:off x="6446520" y="1920240"/>
-            <a:ext cx="4572000" cy="365760"/>
+            <a:off x="6812280" y="3474720"/>
+            <a:ext cx="4160520" cy="320040"/>
           </a:xfrm>
           <a:prstGeom prst="rect">
             <a:avLst/>
@@ -4944,27 +5672,27 @@
           <a:lstStyle/>
           <a:p>
             <a:r>
-              <a:rPr sz="1600" b="1" i="0">
-                <a:solidFill>
-                  <a:srgbClr val="0F6664"/>
-                </a:solidFill>
-                <a:latin typeface="Segoe UI"/>
-              </a:rPr>
-              <a:t>What changes in production</a:t>
-            </a:r>
-          </a:p>
-        </p:txBody>
-      </p:sp>
-      <p:sp>
-        <p:nvSpPr>
-          <p:cNvPr id="12" name="TextBox 11"/>
+              <a:rPr sz="1450" b="1" i="0">
+                <a:solidFill>
+                  <a:srgbClr val="14253A"/>
+                </a:solidFill>
+                <a:latin typeface="Segoe UI"/>
+              </a:rPr>
+              <a:t>CI pipeline</a:t>
+            </a:r>
+          </a:p>
+        </p:txBody>
+      </p:sp>
+      <p:sp>
+        <p:nvSpPr>
+          <p:cNvPr id="31" name="TextBox 30"/>
           <p:cNvSpPr txBox="1"/>
           <p:nvPr/>
         </p:nvSpPr>
         <p:spPr>
           <a:xfrm>
-            <a:off x="6446520" y="2395728"/>
-            <a:ext cx="4526280" cy="3474720"/>
+            <a:off x="6400800" y="3867911"/>
+            <a:ext cx="4617720" cy="640080"/>
           </a:xfrm>
           <a:prstGeom prst="rect">
             <a:avLst/>
@@ -4979,129 +5707,460 @@
           <a:p>
             <a:pPr>
               <a:lnSpc>
-                <a:spcPct val="110000"/>
+                <a:spcPct val="105000"/>
               </a:lnSpc>
-              <a:spcAft>
-                <a:spcPts val="1300"/>
-              </a:spcAft>
             </a:pPr>
             <a:r>
-              <a:rPr sz="1280" b="1" i="0">
-                <a:solidFill>
-                  <a:srgbClr val="168A86"/>
-                </a:solidFill>
-                <a:latin typeface="Segoe UI"/>
-              </a:rPr>
-              <a:t>▸  </a:t>
-            </a:r>
-            <a:r>
-              <a:rPr sz="1280" b="0" i="0">
+              <a:rPr sz="1250" b="0" i="0">
                 <a:solidFill>
                   <a:srgbClr val="1E242B"/>
                 </a:solidFill>
                 <a:latin typeface="Segoe UI"/>
               </a:rPr>
-              <a:t>RDS for PostgreSQL and managed SQS/S3, instead of a self-hosted Postgres pod and LocalStack</a:t>
-            </a:r>
-          </a:p>
+              <a:t>Every change: tests, security scan, build, tag with the commit SHA, push to the registry, then update the GitOps repo's tag.</a:t>
+            </a:r>
+          </a:p>
+        </p:txBody>
+      </p:sp>
+      <p:sp>
+        <p:nvSpPr>
+          <p:cNvPr id="32" name="Rounded Rectangle 31"/>
+          <p:cNvSpPr/>
+          <p:nvPr/>
+        </p:nvSpPr>
+        <p:spPr>
+          <a:xfrm>
+            <a:off x="640080" y="4754880"/>
+            <a:ext cx="5074920" cy="1234440"/>
+          </a:xfrm>
+          <a:prstGeom prst="roundRect">
+            <a:avLst>
+              <a:gd name="adj" fmla="val 3500"/>
+            </a:avLst>
+          </a:prstGeom>
+          <a:solidFill>
+            <a:srgbClr val="FFFFFF"/>
+          </a:solidFill>
+          <a:ln w="9525">
+            <a:solidFill>
+              <a:srgbClr val="E1E5EA"/>
+            </a:solidFill>
+          </a:ln>
+          <a:effectLst/>
+        </p:spPr>
+        <p:style>
+          <a:lnRef idx="1">
+            <a:schemeClr val="accent1"/>
+          </a:lnRef>
+          <a:fillRef idx="3">
+            <a:schemeClr val="accent1"/>
+          </a:fillRef>
+          <a:effectRef idx="2">
+            <a:schemeClr val="accent1"/>
+          </a:effectRef>
+          <a:fontRef idx="minor">
+            <a:schemeClr val="lt1"/>
+          </a:fontRef>
+        </p:style>
+        <p:txBody>
+          <a:bodyPr rtlCol="0" anchor="ctr"/>
+          <a:lstStyle/>
+          <a:p>
+            <a:pPr algn="ctr"/>
+          </a:p>
+        </p:txBody>
+      </p:sp>
+      <p:sp>
+        <p:nvSpPr>
+          <p:cNvPr id="33" name="Rectangle 32"/>
+          <p:cNvSpPr/>
+          <p:nvPr/>
+        </p:nvSpPr>
+        <p:spPr>
+          <a:xfrm>
+            <a:off x="786384" y="4754880"/>
+            <a:ext cx="4782312" cy="40640"/>
+          </a:xfrm>
+          <a:prstGeom prst="rect">
+            <a:avLst/>
+          </a:prstGeom>
+          <a:solidFill>
+            <a:srgbClr val="0F6664"/>
+          </a:solidFill>
+          <a:ln>
+            <a:noFill/>
+          </a:ln>
+          <a:effectLst/>
+        </p:spPr>
+        <p:style>
+          <a:lnRef idx="1">
+            <a:schemeClr val="accent1"/>
+          </a:lnRef>
+          <a:fillRef idx="3">
+            <a:schemeClr val="accent1"/>
+          </a:fillRef>
+          <a:effectRef idx="2">
+            <a:schemeClr val="accent1"/>
+          </a:effectRef>
+          <a:fontRef idx="minor">
+            <a:schemeClr val="lt1"/>
+          </a:fontRef>
+        </p:style>
+        <p:txBody>
+          <a:bodyPr rtlCol="0" anchor="ctr"/>
+          <a:lstStyle/>
+          <a:p>
+            <a:pPr algn="ctr"/>
+          </a:p>
+        </p:txBody>
+      </p:sp>
+      <p:sp>
+        <p:nvSpPr>
+          <p:cNvPr id="34" name="Oval 33"/>
+          <p:cNvSpPr/>
+          <p:nvPr/>
+        </p:nvSpPr>
+        <p:spPr>
+          <a:xfrm>
+            <a:off x="868680" y="4937760"/>
+            <a:ext cx="292608" cy="292608"/>
+          </a:xfrm>
+          <a:prstGeom prst="ellipse">
+            <a:avLst/>
+          </a:prstGeom>
+          <a:solidFill>
+            <a:srgbClr val="0F6664"/>
+          </a:solidFill>
+          <a:ln>
+            <a:noFill/>
+          </a:ln>
+          <a:effectLst/>
+        </p:spPr>
+        <p:style>
+          <a:lnRef idx="1">
+            <a:schemeClr val="accent1"/>
+          </a:lnRef>
+          <a:fillRef idx="3">
+            <a:schemeClr val="accent1"/>
+          </a:fillRef>
+          <a:effectRef idx="2">
+            <a:schemeClr val="accent1"/>
+          </a:effectRef>
+          <a:fontRef idx="minor">
+            <a:schemeClr val="lt1"/>
+          </a:fontRef>
+        </p:style>
+        <p:txBody>
+          <a:bodyPr rtlCol="0" anchor="ctr" wrap="none" lIns="0" rIns="0"/>
+          <a:lstStyle/>
+          <a:p>
+            <a:pPr algn="ctr"/>
+            <a:r>
+              <a:rPr sz="1250" b="1" i="0">
+                <a:solidFill>
+                  <a:srgbClr val="FFFFFF"/>
+                </a:solidFill>
+                <a:latin typeface="Segoe UI"/>
+              </a:rPr>
+              <a:t>3</a:t>
+            </a:r>
+          </a:p>
+        </p:txBody>
+      </p:sp>
+      <p:sp>
+        <p:nvSpPr>
+          <p:cNvPr id="35" name="TextBox 34"/>
+          <p:cNvSpPr txBox="1"/>
+          <p:nvPr/>
+        </p:nvSpPr>
+        <p:spPr>
+          <a:xfrm>
+            <a:off x="1280160" y="4892040"/>
+            <a:ext cx="4160520" cy="320040"/>
+          </a:xfrm>
+          <a:prstGeom prst="rect">
+            <a:avLst/>
+          </a:prstGeom>
+          <a:noFill/>
+        </p:spPr>
+        <p:txBody>
+          <a:bodyPr wrap="none">
+            <a:spAutoFit/>
+          </a:bodyPr>
+          <a:lstStyle/>
+          <a:p>
+            <a:r>
+              <a:rPr sz="1450" b="1" i="0">
+                <a:solidFill>
+                  <a:srgbClr val="14253A"/>
+                </a:solidFill>
+                <a:latin typeface="Segoe UI"/>
+              </a:rPr>
+              <a:t>Argo CD deployment</a:t>
+            </a:r>
+          </a:p>
+        </p:txBody>
+      </p:sp>
+      <p:sp>
+        <p:nvSpPr>
+          <p:cNvPr id="36" name="TextBox 35"/>
+          <p:cNvSpPr txBox="1"/>
+          <p:nvPr/>
+        </p:nvSpPr>
+        <p:spPr>
+          <a:xfrm>
+            <a:off x="868680" y="5285232"/>
+            <a:ext cx="4617720" cy="640080"/>
+          </a:xfrm>
+          <a:prstGeom prst="rect">
+            <a:avLst/>
+          </a:prstGeom>
+          <a:noFill/>
+        </p:spPr>
+        <p:txBody>
+          <a:bodyPr wrap="square">
+            <a:spAutoFit/>
+          </a:bodyPr>
+          <a:lstStyle/>
           <a:p>
             <a:pPr>
               <a:lnSpc>
-                <a:spcPct val="110000"/>
+                <a:spcPct val="105000"/>
               </a:lnSpc>
-              <a:spcAft>
-                <a:spcPts val="1300"/>
-              </a:spcAft>
             </a:pPr>
             <a:r>
-              <a:rPr sz="1280" b="1" i="0">
-                <a:solidFill>
-                  <a:srgbClr val="168A86"/>
-                </a:solidFill>
-                <a:latin typeface="Segoe UI"/>
-              </a:rPr>
-              <a:t>▸  </a:t>
-            </a:r>
-            <a:r>
-              <a:rPr sz="1280" b="0" i="0">
+              <a:rPr sz="1250" b="0" i="0">
                 <a:solidFill>
                   <a:srgbClr val="1E242B"/>
                 </a:solidFill>
                 <a:latin typeface="Segoe UI"/>
               </a:rPr>
-              <a:t>Workload identity (e.g. IRSA) and an external secret manager, instead of static credentials and manual Kubernetes Secrets</a:t>
-            </a:r>
-          </a:p>
+              <a:t>Argo CD syncs the GitOps repo into the cluster — changes reviewed via Git, rollback by reverting to a known-good commit.</a:t>
+            </a:r>
+          </a:p>
+        </p:txBody>
+      </p:sp>
+      <p:sp>
+        <p:nvSpPr>
+          <p:cNvPr id="37" name="Rounded Rectangle 36"/>
+          <p:cNvSpPr/>
+          <p:nvPr/>
+        </p:nvSpPr>
+        <p:spPr>
+          <a:xfrm>
+            <a:off x="6172200" y="4754880"/>
+            <a:ext cx="5074920" cy="1234440"/>
+          </a:xfrm>
+          <a:prstGeom prst="roundRect">
+            <a:avLst>
+              <a:gd name="adj" fmla="val 3500"/>
+            </a:avLst>
+          </a:prstGeom>
+          <a:solidFill>
+            <a:srgbClr val="FFFFFF"/>
+          </a:solidFill>
+          <a:ln w="9525">
+            <a:solidFill>
+              <a:srgbClr val="E1E5EA"/>
+            </a:solidFill>
+          </a:ln>
+          <a:effectLst/>
+        </p:spPr>
+        <p:style>
+          <a:lnRef idx="1">
+            <a:schemeClr val="accent1"/>
+          </a:lnRef>
+          <a:fillRef idx="3">
+            <a:schemeClr val="accent1"/>
+          </a:fillRef>
+          <a:effectRef idx="2">
+            <a:schemeClr val="accent1"/>
+          </a:effectRef>
+          <a:fontRef idx="minor">
+            <a:schemeClr val="lt1"/>
+          </a:fontRef>
+        </p:style>
+        <p:txBody>
+          <a:bodyPr rtlCol="0" anchor="ctr"/>
+          <a:lstStyle/>
+          <a:p>
+            <a:pPr algn="ctr"/>
+          </a:p>
+        </p:txBody>
+      </p:sp>
+      <p:sp>
+        <p:nvSpPr>
+          <p:cNvPr id="38" name="Rectangle 37"/>
+          <p:cNvSpPr/>
+          <p:nvPr/>
+        </p:nvSpPr>
+        <p:spPr>
+          <a:xfrm>
+            <a:off x="6318504" y="4754880"/>
+            <a:ext cx="4782312" cy="40640"/>
+          </a:xfrm>
+          <a:prstGeom prst="rect">
+            <a:avLst/>
+          </a:prstGeom>
+          <a:solidFill>
+            <a:srgbClr val="14253A"/>
+          </a:solidFill>
+          <a:ln>
+            <a:noFill/>
+          </a:ln>
+          <a:effectLst/>
+        </p:spPr>
+        <p:style>
+          <a:lnRef idx="1">
+            <a:schemeClr val="accent1"/>
+          </a:lnRef>
+          <a:fillRef idx="3">
+            <a:schemeClr val="accent1"/>
+          </a:fillRef>
+          <a:effectRef idx="2">
+            <a:schemeClr val="accent1"/>
+          </a:effectRef>
+          <a:fontRef idx="minor">
+            <a:schemeClr val="lt1"/>
+          </a:fontRef>
+        </p:style>
+        <p:txBody>
+          <a:bodyPr rtlCol="0" anchor="ctr"/>
+          <a:lstStyle/>
+          <a:p>
+            <a:pPr algn="ctr"/>
+          </a:p>
+        </p:txBody>
+      </p:sp>
+      <p:sp>
+        <p:nvSpPr>
+          <p:cNvPr id="39" name="Oval 38"/>
+          <p:cNvSpPr/>
+          <p:nvPr/>
+        </p:nvSpPr>
+        <p:spPr>
+          <a:xfrm>
+            <a:off x="6400800" y="4937760"/>
+            <a:ext cx="292608" cy="292608"/>
+          </a:xfrm>
+          <a:prstGeom prst="ellipse">
+            <a:avLst/>
+          </a:prstGeom>
+          <a:solidFill>
+            <a:srgbClr val="14253A"/>
+          </a:solidFill>
+          <a:ln>
+            <a:noFill/>
+          </a:ln>
+          <a:effectLst/>
+        </p:spPr>
+        <p:style>
+          <a:lnRef idx="1">
+            <a:schemeClr val="accent1"/>
+          </a:lnRef>
+          <a:fillRef idx="3">
+            <a:schemeClr val="accent1"/>
+          </a:fillRef>
+          <a:effectRef idx="2">
+            <a:schemeClr val="accent1"/>
+          </a:effectRef>
+          <a:fontRef idx="minor">
+            <a:schemeClr val="lt1"/>
+          </a:fontRef>
+        </p:style>
+        <p:txBody>
+          <a:bodyPr rtlCol="0" anchor="ctr" wrap="none" lIns="0" rIns="0"/>
+          <a:lstStyle/>
+          <a:p>
+            <a:pPr algn="ctr"/>
+            <a:r>
+              <a:rPr sz="1250" b="1" i="0">
+                <a:solidFill>
+                  <a:srgbClr val="FFFFFF"/>
+                </a:solidFill>
+                <a:latin typeface="Segoe UI"/>
+              </a:rPr>
+              <a:t>4</a:t>
+            </a:r>
+          </a:p>
+        </p:txBody>
+      </p:sp>
+      <p:sp>
+        <p:nvSpPr>
+          <p:cNvPr id="40" name="TextBox 39"/>
+          <p:cNvSpPr txBox="1"/>
+          <p:nvPr/>
+        </p:nvSpPr>
+        <p:spPr>
+          <a:xfrm>
+            <a:off x="6812280" y="4892040"/>
+            <a:ext cx="4160520" cy="320040"/>
+          </a:xfrm>
+          <a:prstGeom prst="rect">
+            <a:avLst/>
+          </a:prstGeom>
+          <a:noFill/>
+        </p:spPr>
+        <p:txBody>
+          <a:bodyPr wrap="none">
+            <a:spAutoFit/>
+          </a:bodyPr>
+          <a:lstStyle/>
+          <a:p>
+            <a:r>
+              <a:rPr sz="1450" b="1" i="0">
+                <a:solidFill>
+                  <a:srgbClr val="14253A"/>
+                </a:solidFill>
+                <a:latin typeface="Segoe UI"/>
+              </a:rPr>
+              <a:t>Production reliability</a:t>
+            </a:r>
+          </a:p>
+        </p:txBody>
+      </p:sp>
+      <p:sp>
+        <p:nvSpPr>
+          <p:cNvPr id="41" name="TextBox 40"/>
+          <p:cNvSpPr txBox="1"/>
+          <p:nvPr/>
+        </p:nvSpPr>
+        <p:spPr>
+          <a:xfrm>
+            <a:off x="6400800" y="5285232"/>
+            <a:ext cx="4617720" cy="640080"/>
+          </a:xfrm>
+          <a:prstGeom prst="rect">
+            <a:avLst/>
+          </a:prstGeom>
+          <a:noFill/>
+        </p:spPr>
+        <p:txBody>
+          <a:bodyPr wrap="square">
+            <a:spAutoFit/>
+          </a:bodyPr>
+          <a:lstStyle/>
           <a:p>
             <a:pPr>
               <a:lnSpc>
-                <a:spcPct val="110000"/>
+                <a:spcPct val="105000"/>
               </a:lnSpc>
-              <a:spcAft>
-                <a:spcPts val="1300"/>
-              </a:spcAft>
             </a:pPr>
             <a:r>
-              <a:rPr sz="1280" b="1" i="0">
-                <a:solidFill>
-                  <a:srgbClr val="168A86"/>
-                </a:solidFill>
-                <a:latin typeface="Segoe UI"/>
-              </a:rPr>
-              <a:t>▸  </a:t>
-            </a:r>
-            <a:r>
-              <a:rPr sz="1280" b="0" i="0">
+              <a:rPr sz="1250" b="0" i="0">
                 <a:solidFill>
                   <a:srgbClr val="1E242B"/>
                 </a:solidFill>
                 <a:latin typeface="Segoe UI"/>
               </a:rPr>
-              <a:t>High availability, autoscaling on queue depth, persistent metrics storage, real alert routing</a:t>
-            </a:r>
-          </a:p>
-          <a:p>
-            <a:pPr>
-              <a:lnSpc>
-                <a:spcPct val="110000"/>
-              </a:lnSpc>
-              <a:spcAft>
-                <a:spcPts val="1300"/>
-              </a:spcAft>
-            </a:pPr>
-            <a:r>
-              <a:rPr sz="1280" b="1" i="0">
-                <a:solidFill>
-                  <a:srgbClr val="168A86"/>
-                </a:solidFill>
-                <a:latin typeface="Segoe UI"/>
-              </a:rPr>
-              <a:t>▸  </a:t>
-            </a:r>
-            <a:r>
-              <a:rPr sz="1280" b="1" i="0">
-                <a:solidFill>
-                  <a:srgbClr val="14253A"/>
-                </a:solidFill>
-                <a:latin typeface="Segoe UI"/>
-              </a:rPr>
-              <a:t>Narrowing</a:t>
-            </a:r>
-            <a:r>
-              <a:rPr sz="1280" b="0" i="0">
-                <a:solidFill>
-                  <a:srgbClr val="1E242B"/>
-                </a:solidFill>
-                <a:latin typeface="Segoe UI"/>
-              </a:rPr>
-              <a:t> — not fully closing — the OpenAI-response-to-commit duplicate window, e.g. with an idempotency key on the LLM call</a:t>
-            </a:r>
-          </a:p>
-        </p:txBody>
-      </p:sp>
-      <p:sp>
-        <p:nvSpPr>
-          <p:cNvPr id="13" name="Rectangle 12"/>
+              <a:t>Managed RDS/SQS/S3/DLQ, a cloud secret manager and workload identity, multiple replicas, queue-depth autoscaling, monitoring and backups.</a:t>
+            </a:r>
+          </a:p>
+        </p:txBody>
+      </p:sp>
+      <p:sp>
+        <p:nvSpPr>
+          <p:cNvPr id="42" name="Rectangle 41"/>
           <p:cNvSpPr/>
           <p:nvPr/>
         </p:nvSpPr>
@@ -5145,7 +6204,7 @@
       </p:sp>
       <p:sp>
         <p:nvSpPr>
-          <p:cNvPr id="14" name="TextBox 13"/>
+          <p:cNvPr id="43" name="TextBox 42"/>
           <p:cNvSpPr txBox="1"/>
           <p:nvPr/>
         </p:nvSpPr>
@@ -5172,14 +6231,14 @@
                 </a:solidFill>
                 <a:latin typeface="Segoe UI"/>
               </a:rPr>
-              <a:t>ConvoScore  ·  Tradeoffs and roadmap</a:t>
-            </a:r>
-          </a:p>
-        </p:txBody>
-      </p:sp>
-      <p:sp>
-        <p:nvSpPr>
-          <p:cNvPr id="15" name="TextBox 14"/>
+              <a:t>ConvoScore  ·  Production roadmap</a:t>
+            </a:r>
+          </a:p>
+        </p:txBody>
+      </p:sp>
+      <p:sp>
+        <p:nvSpPr>
+          <p:cNvPr id="44" name="TextBox 43"/>
           <p:cNvSpPr txBox="1"/>
           <p:nvPr/>
         </p:nvSpPr>

</xml_diff>